<commit_message>
Deck visual QA: fix slide 2 title overlap, drop Jev mention
Co-Authored-By: Claude Opus 5.5 <noreply@anthropic.com>
Claude-Session: https://claude.ai/code/session_01R2t3DQ3WiMBbtueYMbxJvA
</commit_message>
<xml_diff>
--- a/docs/EchoFlow_Presentation.pptx
+++ b/docs/EchoFlow_Presentation.pptx
@@ -2847,7 +2847,7 @@
                 <a:ea typeface="Calibri" pitchFamily="34" charset="-122"/>
                 <a:cs typeface="Calibri" pitchFamily="34" charset="-120"/>
               </a:rPr>
-              <a:t>Typed decision models (e.g. Jev) for fast, calibrated matching</a:t>
+              <a:t>Typed decision models for fast, calibrated matching</a:t>
             </a:r>
             <a:endParaRPr lang="en-US" sz="1300" dirty="0"/>
           </a:p>
@@ -3680,7 +3680,7 @@
                 <a:ea typeface="Cambria" pitchFamily="34" charset="-122"/>
                 <a:cs typeface="Cambria" pitchFamily="34" charset="-120"/>
               </a:rPr>
-              <a:t>Never touch money</a:t>
+              <a:t>Never pay</a:t>
             </a:r>
             <a:endParaRPr lang="en-US" sz="1900" dirty="0"/>
           </a:p>

</xml_diff>